<commit_message>
feat: add editable energy factors and pitch updates
</commit_message>
<xml_diff>
--- a/pitch/Akeso-ICON-Lyra-Pitch-Revised.pptx
+++ b/pitch/Akeso-ICON-Lyra-Pitch-Revised.pptx
@@ -2471,7 +2471,7 @@
       </p:sp>
       <p:pic>
         <p:nvPicPr>
-          <p:cNvPr id="18" name="Image 0" descr="/Users/edwinj/Edwin/second-brain/01-projects/UNSWHac/pitch/assets/mascot-celebrate.png">    </p:cNvPr>
+          <p:cNvPr id="18" name="Image 0" descr="mascot-celebrate.png">    </p:cNvPr>
           <p:cNvPicPr>
             <a:picLocks noChangeAspect="1"/>
           </p:cNvPicPr>
@@ -2766,12 +2766,12 @@
         </p:nvSpPr>
         <p:spPr>
           <a:xfrm>
-            <a:off x="1606600" y="1615380"/>
-            <a:ext cx="5930801" cy="3416201"/>
+            <a:off x="1809750" y="1640830"/>
+            <a:ext cx="5524500" cy="3187601"/>
           </a:xfrm>
           <a:prstGeom prst="roundRect">
             <a:avLst>
-              <a:gd name="adj" fmla="val 5205"/>
+              <a:gd name="adj" fmla="val 5578"/>
             </a:avLst>
           </a:prstGeom>
           <a:solidFill>
@@ -2796,7 +2796,7 @@
       </p:sp>
       <p:pic>
         <p:nvPicPr>
-          <p:cNvPr id="6" name="Image 0" descr="/Users/edwinj/Edwin/second-brain/01-projects/UNSWHac/pitch/team-introduction-pixel-art-v5-distinct-faces.png">    </p:cNvPr>
+          <p:cNvPr id="6" name="Image 0" descr="team-introduction-pixel-art-v5-distinct-faces.png">    </p:cNvPr>
           <p:cNvPicPr>
             <a:picLocks noChangeAspect="1"/>
           </p:cNvPicPr>
@@ -2810,8 +2810,8 @@
         </p:blipFill>
         <p:spPr>
           <a:xfrm>
-            <a:off x="1701850" y="1710630"/>
-            <a:ext cx="5740301" cy="3225701"/>
+            <a:off x="1905000" y="1736080"/>
+            <a:ext cx="5334000" cy="2997101"/>
           </a:xfrm>
           <a:prstGeom prst="rect">
             <a:avLst/>
@@ -3208,7 +3208,7 @@
                 <a:ea typeface="Arial" pitchFamily="34" charset="-122"/>
                 <a:cs typeface="Arial" pitchFamily="34" charset="-120"/>
               </a:rPr>
-              <a:t>NEXT · EMOTION COACH</a:t>
+              <a:t>NEXT · EMOTION COACH</a:t>
             </a:r>
             <a:endParaRPr lang="en-US" sz="900" dirty="0"/>
           </a:p>
@@ -3286,7 +3286,7 @@
                 <a:ea typeface="Arial" pitchFamily="34" charset="-122"/>
                 <a:cs typeface="Arial" pitchFamily="34" charset="-120"/>
               </a:rPr>
-              <a:t>PHOTO FOOD LOGGING</a:t>
+              <a:t>PHOTO FOOD LOGGING</a:t>
             </a:r>
             <a:endParaRPr lang="en-US" sz="900" dirty="0"/>
           </a:p>
@@ -3301,7 +3301,7 @@
         <p:spPr>
           <a:xfrm>
             <a:off x="3858369" y="3485555"/>
-            <a:ext cx="1380232" cy="285155"/>
+            <a:ext cx="1441252" cy="285155"/>
           </a:xfrm>
           <a:prstGeom prst="roundRect">
             <a:avLst>
@@ -3336,20 +3336,20 @@
         </p:nvSpPr>
         <p:spPr>
           <a:xfrm>
-            <a:off x="3994845" y="3558480"/>
-            <a:ext cx="1129427" cy="139303"/>
-          </a:xfrm>
-          <a:prstGeom prst="rect">
-            <a:avLst/>
-          </a:prstGeom>
-          <a:noFill/>
-          <a:ln/>
-        </p:spPr>
-        <p:txBody>
-          <a:bodyPr wrap="square" lIns="0" tIns="0" rIns="0" bIns="0" rtlCol="0" anchor="t"/>
-          <a:lstStyle/>
-          <a:p>
-            <a:pPr algn="l" indent="0" marL="0">
+            <a:off x="3983162" y="3558480"/>
+            <a:ext cx="1191667" cy="139303"/>
+          </a:xfrm>
+          <a:prstGeom prst="rect">
+            <a:avLst/>
+          </a:prstGeom>
+          <a:noFill/>
+          <a:ln/>
+        </p:spPr>
+        <p:txBody>
+          <a:bodyPr wrap="square" lIns="0" tIns="0" rIns="0" bIns="0" rtlCol="0" anchor="t"/>
+          <a:lstStyle/>
+          <a:p>
+            <a:pPr algn="ctr" indent="0" marL="0">
               <a:lnSpc>
                 <a:spcPts val="1098"/>
               </a:lnSpc>
@@ -3364,7 +3364,7 @@
                 <a:ea typeface="Arial" pitchFamily="34" charset="-122"/>
                 <a:cs typeface="Arial" pitchFamily="34" charset="-120"/>
               </a:rPr>
-              <a:t>WEEKLY PATTERNS</a:t>
+              <a:t>WEEKLY PATTERNS</a:t>
             </a:r>
             <a:endParaRPr lang="en-US" sz="900" dirty="0"/>
           </a:p>
@@ -3520,7 +3520,7 @@
                 <a:ea typeface="Arial" pitchFamily="34" charset="-122"/>
                 <a:cs typeface="Arial" pitchFamily="34" charset="-120"/>
               </a:rPr>
-              <a:t>EXPERT-REVIEWED GUIDANCE</a:t>
+              <a:t>EXPERT-REVIEWED GUIDANCE</a:t>
             </a:r>
             <a:endParaRPr lang="en-US" sz="900" dirty="0"/>
           </a:p>
@@ -3609,7 +3609,7 @@
       </p:sp>
       <p:pic>
         <p:nvPicPr>
-          <p:cNvPr id="18" name="Image 0" descr="/Users/edwinj/Edwin/second-brain/01-projects/UNSWHac/pitch/assets/mascot-celebrate.png">    </p:cNvPr>
+          <p:cNvPr id="18" name="Image 0" descr="mascot-celebrate.png">    </p:cNvPr>
           <p:cNvPicPr>
             <a:picLocks noChangeAspect="1"/>
           </p:cNvPicPr>
@@ -3892,7 +3892,7 @@
       </p:sp>
       <p:pic>
         <p:nvPicPr>
-          <p:cNvPr id="5" name="Image 0" descr="/Users/edwinj/Edwin/second-brain/01-projects/UNSWHac/pitch/assets/meme-high-cortisol.jpg">    </p:cNvPr>
+          <p:cNvPr id="5" name="Image 0" descr="/private/tmp/claude-501/-Users-edwinj-Edwin-second-brain-01-projects-UNSWHac/03424ec2-0cbc-497a-893e-ecb97b634aec/scratchpad/build/work/meme-high.jpg">    </p:cNvPr>
           <p:cNvPicPr>
             <a:picLocks noChangeAspect="1"/>
           </p:cNvPicPr>
@@ -3997,7 +3997,7 @@
       </p:sp>
       <p:pic>
         <p:nvPicPr>
-          <p:cNvPr id="8" name="Image 1" descr="/Users/edwinj/Edwin/second-brain/01-projects/UNSWHac/pitch/assets/meme-low-cortisol.jpg">    </p:cNvPr>
+          <p:cNvPr id="8" name="Image 1" descr="/private/tmp/claude-501/-Users-edwinj-Edwin-second-brain-01-projects-UNSWHac/03424ec2-0cbc-497a-893e-ecb97b634aec/scratchpad/build/work/meme-low.jpg">    </p:cNvPr>
           <p:cNvPicPr>
             <a:picLocks noChangeAspect="1"/>
           </p:cNvPicPr>
@@ -5141,7 +5141,7 @@
       </p:sp>
       <p:pic>
         <p:nvPicPr>
-          <p:cNvPr id="6" name="Image 0" descr="/Users/edwinj/Edwin/second-brain/01-projects/UNSWHac/pitch/assets/mascot-steady.png">    </p:cNvPr>
+          <p:cNvPr id="6" name="Image 0" descr="mascot-steady.png">    </p:cNvPr>
           <p:cNvPicPr>
             <a:picLocks noChangeAspect="1"/>
           </p:cNvPicPr>
@@ -5866,27 +5866,27 @@
         </p:nvSpPr>
         <p:spPr>
           <a:xfrm>
-            <a:off x="381000" y="850404"/>
-            <a:ext cx="5246370" cy="1796058"/>
-          </a:xfrm>
-          <a:prstGeom prst="rect">
-            <a:avLst/>
-          </a:prstGeom>
-          <a:noFill/>
-          <a:ln/>
-        </p:spPr>
-        <p:txBody>
-          <a:bodyPr wrap="square" lIns="0" tIns="0" rIns="0" bIns="0" rtlCol="0" anchor="t"/>
-          <a:lstStyle/>
-          <a:p>
-            <a:pPr algn="l" indent="0" marL="0">
-              <a:lnSpc>
-                <a:spcPts val="3536"/>
-              </a:lnSpc>
-              <a:buNone/>
-            </a:pPr>
-            <a:r>
-              <a:rPr lang="en-US" sz="3400" dirty="0">
+            <a:off x="381000" y="1134517"/>
+            <a:ext cx="5246370" cy="1227832"/>
+          </a:xfrm>
+          <a:prstGeom prst="rect">
+            <a:avLst/>
+          </a:prstGeom>
+          <a:noFill/>
+          <a:ln/>
+        </p:spPr>
+        <p:txBody>
+          <a:bodyPr wrap="square" lIns="0" tIns="0" rIns="0" bIns="0" rtlCol="0" anchor="t"/>
+          <a:lstStyle/>
+          <a:p>
+            <a:pPr algn="l" indent="0" marL="0">
+              <a:lnSpc>
+                <a:spcPts val="3224"/>
+              </a:lnSpc>
+              <a:buNone/>
+            </a:pPr>
+            <a:r>
+              <a:rPr lang="en-US" sz="3100" dirty="0">
                 <a:solidFill>
                   <a:srgbClr val="F5F2E8"/>
                 </a:solidFill>
@@ -5896,17 +5896,17 @@
               </a:rPr>
               <a:t>A PERSONAL</a:t>
             </a:r>
-            <a:endParaRPr lang="en-US" sz="3400" dirty="0"/>
-          </a:p>
-          <a:p>
-            <a:pPr algn="l" indent="0" marL="0">
-              <a:lnSpc>
-                <a:spcPts val="3536"/>
-              </a:lnSpc>
-              <a:buNone/>
-            </a:pPr>
-            <a:r>
-              <a:rPr lang="en-US" sz="3400" dirty="0">
+            <a:endParaRPr lang="en-US" sz="3100" dirty="0"/>
+          </a:p>
+          <a:p>
+            <a:pPr algn="l" indent="0" marL="0">
+              <a:lnSpc>
+                <a:spcPts val="3224"/>
+              </a:lnSpc>
+              <a:buNone/>
+            </a:pPr>
+            <a:r>
+              <a:rPr lang="en-US" sz="3100" dirty="0">
                 <a:solidFill>
                   <a:srgbClr val="F5F2E8"/>
                 </a:solidFill>
@@ -5916,17 +5916,17 @@
               </a:rPr>
               <a:t>ENERGY + NUTRITION</a:t>
             </a:r>
-            <a:endParaRPr lang="en-US" sz="3400" dirty="0"/>
-          </a:p>
-          <a:p>
-            <a:pPr algn="l" indent="0" marL="0">
-              <a:lnSpc>
-                <a:spcPts val="3536"/>
-              </a:lnSpc>
-              <a:buNone/>
-            </a:pPr>
-            <a:r>
-              <a:rPr lang="en-US" sz="3400" dirty="0">
+            <a:endParaRPr lang="en-US" sz="3100" dirty="0"/>
+          </a:p>
+          <a:p>
+            <a:pPr algn="l" indent="0" marL="0">
+              <a:lnSpc>
+                <a:spcPts val="3224"/>
+              </a:lnSpc>
+              <a:buNone/>
+            </a:pPr>
+            <a:r>
+              <a:rPr lang="en-US" sz="3100" dirty="0">
                 <a:solidFill>
                   <a:srgbClr val="F5F2E8"/>
                 </a:solidFill>
@@ -5936,7 +5936,7 @@
               </a:rPr>
               <a:t>COACH.</a:t>
             </a:r>
-            <a:endParaRPr lang="en-US" sz="3400" dirty="0"/>
+            <a:endParaRPr lang="en-US" sz="3100" dirty="0"/>
           </a:p>
         </p:txBody>
       </p:sp>
@@ -5948,7 +5948,7 @@
         </p:nvSpPr>
         <p:spPr>
           <a:xfrm>
-            <a:off x="381000" y="2849612"/>
+            <a:off x="381000" y="2565499"/>
             <a:ext cx="5246370" cy="738039"/>
           </a:xfrm>
           <a:prstGeom prst="rect">
@@ -5993,7 +5993,7 @@
         </p:nvSpPr>
         <p:spPr>
           <a:xfrm>
-            <a:off x="381000" y="3816251"/>
+            <a:off x="381000" y="3532138"/>
             <a:ext cx="1917650" cy="285155"/>
           </a:xfrm>
           <a:prstGeom prst="roundRect">
@@ -6029,7 +6029,7 @@
         </p:nvSpPr>
         <p:spPr>
           <a:xfrm>
-            <a:off x="517475" y="3889177"/>
+            <a:off x="517475" y="3605064"/>
             <a:ext cx="1677594" cy="139303"/>
           </a:xfrm>
           <a:prstGeom prst="rect">
@@ -6071,7 +6071,7 @@
         </p:nvSpPr>
         <p:spPr>
           <a:xfrm>
-            <a:off x="2400151" y="3816251"/>
+            <a:off x="2400151" y="3532138"/>
             <a:ext cx="1917502" cy="285155"/>
           </a:xfrm>
           <a:prstGeom prst="roundRect">
@@ -6107,7 +6107,7 @@
         </p:nvSpPr>
         <p:spPr>
           <a:xfrm>
-            <a:off x="2536627" y="3889177"/>
+            <a:off x="2536627" y="3605064"/>
             <a:ext cx="1677442" cy="139303"/>
           </a:xfrm>
           <a:prstGeom prst="rect">
@@ -6149,7 +6149,7 @@
         </p:nvSpPr>
         <p:spPr>
           <a:xfrm>
-            <a:off x="381000" y="4291757"/>
+            <a:off x="381000" y="4007644"/>
             <a:ext cx="1663601" cy="285155"/>
           </a:xfrm>
           <a:prstGeom prst="roundRect">
@@ -6185,7 +6185,7 @@
         </p:nvSpPr>
         <p:spPr>
           <a:xfrm>
-            <a:off x="517475" y="4364682"/>
+            <a:off x="517475" y="4080570"/>
             <a:ext cx="1418463" cy="139303"/>
           </a:xfrm>
           <a:prstGeom prst="rect">
@@ -6227,12 +6227,12 @@
         </p:nvSpPr>
         <p:spPr>
           <a:xfrm>
-            <a:off x="5880050" y="808583"/>
-            <a:ext cx="2514600" cy="3810000"/>
+            <a:off x="6604099" y="821382"/>
+            <a:ext cx="1854101" cy="3784550"/>
           </a:xfrm>
           <a:prstGeom prst="roundRect">
             <a:avLst>
-              <a:gd name="adj" fmla="val 7071"/>
+              <a:gd name="adj" fmla="val 9590"/>
             </a:avLst>
           </a:prstGeom>
           <a:solidFill>
@@ -6257,7 +6257,7 @@
       </p:sp>
       <p:pic>
         <p:nvPicPr>
-          <p:cNvPr id="13" name="Image 0" descr="/Users/edwinj/Edwin/second-brain/01-projects/UNSWHac/pitch/assets/akeso-today.jpg">    </p:cNvPr>
+          <p:cNvPr id="13" name="Image 0" descr="akeso-today.jpg">    </p:cNvPr>
           <p:cNvPicPr>
             <a:picLocks noChangeAspect="1"/>
           </p:cNvPicPr>
@@ -6271,8 +6271,8 @@
         </p:blipFill>
         <p:spPr>
           <a:xfrm>
-            <a:off x="6029176" y="957709"/>
-            <a:ext cx="2286000" cy="3581400"/>
+            <a:off x="6753225" y="970508"/>
+            <a:ext cx="1650950" cy="3568601"/>
           </a:xfrm>
           <a:prstGeom prst="rect">
             <a:avLst/>
@@ -6510,12 +6510,12 @@
         </p:nvSpPr>
         <p:spPr>
           <a:xfrm>
-            <a:off x="844451" y="1640830"/>
-            <a:ext cx="1676400" cy="2412950"/>
+            <a:off x="1098500" y="1640830"/>
+            <a:ext cx="1168301" cy="2412950"/>
           </a:xfrm>
           <a:prstGeom prst="roundRect">
             <a:avLst>
-              <a:gd name="adj" fmla="val 10606"/>
+              <a:gd name="adj" fmla="val 15219"/>
             </a:avLst>
           </a:prstGeom>
           <a:solidFill>
@@ -6540,7 +6540,7 @@
       </p:sp>
       <p:pic>
         <p:nvPicPr>
-          <p:cNvPr id="5" name="Image 0" descr="/Users/edwinj/Edwin/second-brain/01-projects/UNSWHac/pitch/assets/akeso-checkin.jpg">    </p:cNvPr>
+          <p:cNvPr id="5" name="Image 0" descr="akeso-checkin.jpg">    </p:cNvPr>
           <p:cNvPicPr>
             <a:picLocks noChangeAspect="1"/>
           </p:cNvPicPr>
@@ -6554,8 +6554,8 @@
         </p:blipFill>
         <p:spPr>
           <a:xfrm>
-            <a:off x="926902" y="1723281"/>
-            <a:ext cx="1524000" cy="2260550"/>
+            <a:off x="1180951" y="1723281"/>
+            <a:ext cx="1041350" cy="2260550"/>
           </a:xfrm>
           <a:prstGeom prst="rect">
             <a:avLst/>
@@ -6693,12 +6693,12 @@
         </p:nvSpPr>
         <p:spPr>
           <a:xfrm>
-            <a:off x="3651052" y="1640830"/>
-            <a:ext cx="1676400" cy="2412950"/>
+            <a:off x="3905101" y="1640830"/>
+            <a:ext cx="1168301" cy="2412950"/>
           </a:xfrm>
           <a:prstGeom prst="roundRect">
             <a:avLst>
-              <a:gd name="adj" fmla="val 10606"/>
+              <a:gd name="adj" fmla="val 15219"/>
             </a:avLst>
           </a:prstGeom>
           <a:solidFill>
@@ -6723,7 +6723,7 @@
       </p:sp>
       <p:pic>
         <p:nvPicPr>
-          <p:cNvPr id="10" name="Image 1" descr="/Users/edwinj/Edwin/second-brain/01-projects/UNSWHac/pitch/assets/akeso-today.jpg">    </p:cNvPr>
+          <p:cNvPr id="10" name="Image 1" descr="akeso-today.jpg">    </p:cNvPr>
           <p:cNvPicPr>
             <a:picLocks noChangeAspect="1"/>
           </p:cNvPicPr>
@@ -6737,8 +6737,8 @@
         </p:blipFill>
         <p:spPr>
           <a:xfrm>
-            <a:off x="3733502" y="1723281"/>
-            <a:ext cx="1524000" cy="2260550"/>
+            <a:off x="3987552" y="1723281"/>
+            <a:ext cx="1041350" cy="2260550"/>
           </a:xfrm>
           <a:prstGeom prst="rect">
             <a:avLst/>
@@ -6876,12 +6876,12 @@
         </p:nvSpPr>
         <p:spPr>
           <a:xfrm>
-            <a:off x="6457652" y="1640830"/>
-            <a:ext cx="1676400" cy="2412950"/>
+            <a:off x="6711702" y="1640830"/>
+            <a:ext cx="1168301" cy="2412950"/>
           </a:xfrm>
           <a:prstGeom prst="roundRect">
             <a:avLst>
-              <a:gd name="adj" fmla="val 10606"/>
+              <a:gd name="adj" fmla="val 15219"/>
             </a:avLst>
           </a:prstGeom>
           <a:solidFill>
@@ -6906,7 +6906,7 @@
       </p:sp>
       <p:pic>
         <p:nvPicPr>
-          <p:cNvPr id="15" name="Image 2" descr="/Users/edwinj/Edwin/second-brain/01-projects/UNSWHac/pitch/assets/akeso-nutrition.jpg">    </p:cNvPr>
+          <p:cNvPr id="15" name="Image 2" descr="akeso-nutrition.jpg">    </p:cNvPr>
           <p:cNvPicPr>
             <a:picLocks noChangeAspect="1"/>
           </p:cNvPicPr>
@@ -6920,8 +6920,8 @@
         </p:blipFill>
         <p:spPr>
           <a:xfrm>
-            <a:off x="6540103" y="1723281"/>
-            <a:ext cx="1524000" cy="2260550"/>
+            <a:off x="6794153" y="1723281"/>
+            <a:ext cx="1041350" cy="2260550"/>
           </a:xfrm>
           <a:prstGeom prst="rect">
             <a:avLst/>
@@ -7283,11 +7283,11 @@
         <p:spPr>
           <a:xfrm>
             <a:off x="381000" y="1691580"/>
-            <a:ext cx="2844701" cy="3124200"/>
+            <a:ext cx="1549301" cy="3124200"/>
           </a:xfrm>
           <a:prstGeom prst="roundRect">
             <a:avLst>
-              <a:gd name="adj" fmla="val 6250"/>
+              <a:gd name="adj" fmla="val 11476"/>
             </a:avLst>
           </a:prstGeom>
           <a:solidFill>
@@ -7312,7 +7312,7 @@
       </p:sp>
       <p:pic>
         <p:nvPicPr>
-          <p:cNvPr id="5" name="Image 0" descr="/Users/edwinj/Edwin/second-brain/01-projects/UNSWHac/pitch/assets/akeso-nutrition.jpg">    </p:cNvPr>
+          <p:cNvPr id="5" name="Image 0" descr="akeso-nutrition.jpg">    </p:cNvPr>
           <p:cNvPicPr>
             <a:picLocks noChangeAspect="1"/>
           </p:cNvPicPr>
@@ -7327,7 +7327,7 @@
         <p:spPr>
           <a:xfrm>
             <a:off x="488900" y="1799481"/>
-            <a:ext cx="2641550" cy="2920901"/>
+            <a:ext cx="1346150" cy="2920901"/>
           </a:xfrm>
           <a:prstGeom prst="rect">
             <a:avLst/>
@@ -7342,8 +7342,8 @@
         </p:nvSpPr>
         <p:spPr>
           <a:xfrm>
-            <a:off x="3454301" y="1691580"/>
-            <a:ext cx="5079950" cy="736550"/>
+            <a:off x="2158901" y="1691580"/>
+            <a:ext cx="6222950" cy="736550"/>
           </a:xfrm>
           <a:prstGeom prst="roundRect">
             <a:avLst>
@@ -7378,7 +7378,7 @@
         </p:nvSpPr>
         <p:spPr>
           <a:xfrm>
-            <a:off x="3625751" y="1863030"/>
+            <a:off x="2330351" y="1863030"/>
             <a:ext cx="393650" cy="393650"/>
           </a:xfrm>
           <a:prstGeom prst="roundRect">
@@ -7410,7 +7410,7 @@
         </p:nvSpPr>
         <p:spPr>
           <a:xfrm>
-            <a:off x="3776662" y="1959173"/>
+            <a:off x="2481263" y="1959173"/>
             <a:ext cx="93663" cy="201216"/>
           </a:xfrm>
           <a:prstGeom prst="rect">
@@ -7452,7 +7452,7 @@
         </p:nvSpPr>
         <p:spPr>
           <a:xfrm>
-            <a:off x="4171801" y="1875681"/>
+            <a:off x="2876401" y="1875681"/>
             <a:ext cx="2994499" cy="209550"/>
           </a:xfrm>
           <a:prstGeom prst="rect">
@@ -7494,7 +7494,7 @@
         </p:nvSpPr>
         <p:spPr>
           <a:xfrm>
-            <a:off x="4171801" y="2085231"/>
+            <a:off x="2876401" y="2085231"/>
             <a:ext cx="2994499" cy="158651"/>
           </a:xfrm>
           <a:prstGeom prst="rect">
@@ -7536,8 +7536,8 @@
         </p:nvSpPr>
         <p:spPr>
           <a:xfrm>
-            <a:off x="3454301" y="2542431"/>
-            <a:ext cx="5079950" cy="736550"/>
+            <a:off x="2158901" y="2542431"/>
+            <a:ext cx="6222950" cy="736550"/>
           </a:xfrm>
           <a:prstGeom prst="roundRect">
             <a:avLst>
@@ -7572,7 +7572,7 @@
         </p:nvSpPr>
         <p:spPr>
           <a:xfrm>
-            <a:off x="3625751" y="2713881"/>
+            <a:off x="2330351" y="2713881"/>
             <a:ext cx="393650" cy="393650"/>
           </a:xfrm>
           <a:prstGeom prst="roundRect">
@@ -7604,7 +7604,7 @@
         </p:nvSpPr>
         <p:spPr>
           <a:xfrm>
-            <a:off x="3776662" y="2810024"/>
+            <a:off x="2481263" y="2810024"/>
             <a:ext cx="93663" cy="201216"/>
           </a:xfrm>
           <a:prstGeom prst="rect">
@@ -7646,7 +7646,7 @@
         </p:nvSpPr>
         <p:spPr>
           <a:xfrm>
-            <a:off x="4171801" y="2726531"/>
+            <a:off x="2876401" y="2726531"/>
             <a:ext cx="2579921" cy="209550"/>
           </a:xfrm>
           <a:prstGeom prst="rect">
@@ -7688,7 +7688,7 @@
         </p:nvSpPr>
         <p:spPr>
           <a:xfrm>
-            <a:off x="4171801" y="2936081"/>
+            <a:off x="2876401" y="2936081"/>
             <a:ext cx="2579921" cy="158651"/>
           </a:xfrm>
           <a:prstGeom prst="rect">
@@ -7730,8 +7730,8 @@
         </p:nvSpPr>
         <p:spPr>
           <a:xfrm>
-            <a:off x="3454301" y="3393281"/>
-            <a:ext cx="5079950" cy="736550"/>
+            <a:off x="2158901" y="3393281"/>
+            <a:ext cx="6222950" cy="736550"/>
           </a:xfrm>
           <a:prstGeom prst="roundRect">
             <a:avLst>
@@ -7766,7 +7766,7 @@
         </p:nvSpPr>
         <p:spPr>
           <a:xfrm>
-            <a:off x="3625751" y="3564731"/>
+            <a:off x="2330351" y="3564731"/>
             <a:ext cx="393650" cy="393650"/>
           </a:xfrm>
           <a:prstGeom prst="roundRect">
@@ -7798,7 +7798,7 @@
         </p:nvSpPr>
         <p:spPr>
           <a:xfrm>
-            <a:off x="3776662" y="3660874"/>
+            <a:off x="2481263" y="3660874"/>
             <a:ext cx="93663" cy="201216"/>
           </a:xfrm>
           <a:prstGeom prst="rect">
@@ -7840,7 +7840,7 @@
         </p:nvSpPr>
         <p:spPr>
           <a:xfrm>
-            <a:off x="4171801" y="3577382"/>
+            <a:off x="2876401" y="3577382"/>
             <a:ext cx="3294617" cy="209550"/>
           </a:xfrm>
           <a:prstGeom prst="rect">
@@ -7882,7 +7882,7 @@
         </p:nvSpPr>
         <p:spPr>
           <a:xfrm>
-            <a:off x="4171801" y="3786932"/>
+            <a:off x="2876401" y="3786932"/>
             <a:ext cx="3294617" cy="158651"/>
           </a:xfrm>
           <a:prstGeom prst="rect">
@@ -7924,8 +7924,8 @@
         </p:nvSpPr>
         <p:spPr>
           <a:xfrm>
-            <a:off x="3454301" y="4282232"/>
-            <a:ext cx="5181549" cy="114300"/>
+            <a:off x="2158901" y="4282232"/>
+            <a:ext cx="6347409" cy="114300"/>
           </a:xfrm>
           <a:prstGeom prst="rect">
             <a:avLst/>

</xml_diff>